<commit_message>
Contents draft: keywords as three stacked lines, block re-centered
Co-Authored-By: Claude Opus 5.5 <noreply@anthropic.com>
Claude-Session: https://claude.ai/code/session_01NTagjVHGZdXLvG9VCNzDRT
</commit_message>
<xml_diff>
--- a/slides/Vitoma_contents_draft.pptx
+++ b/slides/Vitoma_contents_draft.pptx
@@ -736,7 +736,7 @@
         </p:nvSpPr>
         <p:spPr>
           <a:xfrm>
-            <a:off x="533400" y="2009775"/>
+            <a:off x="533400" y="2375535"/>
             <a:ext cx="3557016" cy="2466975"/>
           </a:xfrm>
           <a:custGeom>
@@ -782,7 +782,7 @@
         </p:nvSpPr>
         <p:spPr>
           <a:xfrm>
-            <a:off x="533400" y="2231136"/>
+            <a:off x="533400" y="2596896"/>
             <a:ext cx="3557016" cy="504825"/>
           </a:xfrm>
           <a:prstGeom prst="rect">
@@ -831,7 +831,7 @@
         </p:nvSpPr>
         <p:spPr>
           <a:xfrm>
-            <a:off x="533400" y="2807207"/>
+            <a:off x="533400" y="3172967"/>
             <a:ext cx="3557016" cy="548640"/>
           </a:xfrm>
           <a:prstGeom prst="rect">
@@ -883,7 +883,7 @@
         </p:nvSpPr>
         <p:spPr>
           <a:xfrm>
-            <a:off x="533400" y="3474720"/>
+            <a:off x="533400" y="3840480"/>
             <a:ext cx="3557016" cy="3291840"/>
           </a:xfrm>
           <a:prstGeom prst="rect">
@@ -896,14 +896,21 @@
           </a:bodyPr>
           <a:lstStyle/>
           <a:p>
-            <a:pPr>
+            <a:pPr marL="200025" indent="-200025">
               <a:lnSpc>
-                <a:spcPct val="150000"/>
+                <a:spcPct val="100000"/>
               </a:lnSpc>
-              <a:buNone/>
+              <a:spcAft>
+                <a:spcPts val="900"/>
+              </a:spcAft>
+              <a:buClr>
+                <a:srgbClr val="08A6F6"/>
+              </a:buClr>
+              <a:buFont typeface="Arial"/>
+              <a:buChar char="•"/>
             </a:pPr>
             <a:r>
-              <a:rPr sz="1275">
+              <a:rPr lang="zh-CN" altLang="en-US" sz="1600">
                 <a:solidFill>
                   <a:srgbClr val="44546A"/>
                 </a:solidFill>
@@ -911,16 +918,60 @@
                 <a:ea typeface="微软雅黑"/>
                 <a:cs typeface="微软雅黑"/>
               </a:rPr>
-              <a:t>试错代价 · 临床缺口 · 时机成熟</a:t>
-            </a:r>
-            <a:endParaRPr sz="1275">
-              <a:solidFill>
-                <a:srgbClr val="44546A"/>
-              </a:solidFill>
-              <a:latin typeface="微软雅黑"/>
-              <a:ea typeface="微软雅黑"/>
-              <a:cs typeface="微软雅黑"/>
-            </a:endParaRPr>
+              <a:t>试错代价</a:t>
+            </a:r>
+          </a:p>
+          <a:p>
+            <a:pPr marL="200025" indent="-200025">
+              <a:lnSpc>
+                <a:spcPct val="100000"/>
+              </a:lnSpc>
+              <a:spcAft>
+                <a:spcPts val="900"/>
+              </a:spcAft>
+              <a:buClr>
+                <a:srgbClr val="08A6F6"/>
+              </a:buClr>
+              <a:buFont typeface="Arial"/>
+              <a:buChar char="•"/>
+            </a:pPr>
+            <a:r>
+              <a:rPr lang="zh-CN" altLang="en-US" sz="1600">
+                <a:solidFill>
+                  <a:srgbClr val="44546A"/>
+                </a:solidFill>
+                <a:latin typeface="微软雅黑"/>
+                <a:ea typeface="微软雅黑"/>
+                <a:cs typeface="微软雅黑"/>
+              </a:rPr>
+              <a:t>临床缺口</a:t>
+            </a:r>
+          </a:p>
+          <a:p>
+            <a:pPr marL="200025" indent="-200025">
+              <a:lnSpc>
+                <a:spcPct val="100000"/>
+              </a:lnSpc>
+              <a:spcAft>
+                <a:spcPts val="900"/>
+              </a:spcAft>
+              <a:buClr>
+                <a:srgbClr val="08A6F6"/>
+              </a:buClr>
+              <a:buFont typeface="Arial"/>
+              <a:buChar char="•"/>
+            </a:pPr>
+            <a:r>
+              <a:rPr lang="zh-CN" altLang="en-US" sz="1600">
+                <a:solidFill>
+                  <a:srgbClr val="44546A"/>
+                </a:solidFill>
+                <a:latin typeface="微软雅黑"/>
+                <a:ea typeface="微软雅黑"/>
+                <a:cs typeface="微软雅黑"/>
+              </a:rPr>
+              <a:t>时机成熟</a:t>
+            </a:r>
           </a:p>
         </p:txBody>
       </p:sp>
@@ -934,7 +985,7 @@
         </p:nvSpPr>
         <p:spPr>
           <a:xfrm>
-            <a:off x="4319016" y="2009775"/>
+            <a:off x="4319016" y="2375535"/>
             <a:ext cx="3557016" cy="2466975"/>
           </a:xfrm>
           <a:custGeom>
@@ -980,7 +1031,7 @@
         </p:nvSpPr>
         <p:spPr>
           <a:xfrm>
-            <a:off x="4319016" y="2231136"/>
+            <a:off x="4319016" y="2596896"/>
             <a:ext cx="3557016" cy="504825"/>
           </a:xfrm>
           <a:prstGeom prst="rect">
@@ -1029,7 +1080,7 @@
         </p:nvSpPr>
         <p:spPr>
           <a:xfrm>
-            <a:off x="4319016" y="2807207"/>
+            <a:off x="4319016" y="3172967"/>
             <a:ext cx="3557016" cy="548640"/>
           </a:xfrm>
           <a:prstGeom prst="rect">
@@ -1081,7 +1132,7 @@
         </p:nvSpPr>
         <p:spPr>
           <a:xfrm>
-            <a:off x="4319016" y="3474720"/>
+            <a:off x="4319016" y="3840480"/>
             <a:ext cx="3557016" cy="3291840"/>
           </a:xfrm>
           <a:prstGeom prst="rect">
@@ -1094,14 +1145,21 @@
           </a:bodyPr>
           <a:lstStyle/>
           <a:p>
-            <a:pPr>
+            <a:pPr marL="200025" indent="-200025">
               <a:lnSpc>
-                <a:spcPct val="150000"/>
+                <a:spcPct val="100000"/>
               </a:lnSpc>
-              <a:buNone/>
+              <a:spcAft>
+                <a:spcPts val="900"/>
+              </a:spcAft>
+              <a:buClr>
+                <a:srgbClr val="08A6F6"/>
+              </a:buClr>
+              <a:buFont typeface="Arial"/>
+              <a:buChar char="•"/>
             </a:pPr>
             <a:r>
-              <a:rPr sz="1275">
+              <a:rPr lang="zh-CN" altLang="en-US" sz="1600">
                 <a:solidFill>
                   <a:srgbClr val="44546A"/>
                 </a:solidFill>
@@ -1109,16 +1167,60 @@
                 <a:ea typeface="微软雅黑"/>
                 <a:cs typeface="微软雅黑"/>
               </a:rPr>
-              <a:t>双轨校准 · 数据飞轮 · 核心团队</a:t>
-            </a:r>
-            <a:endParaRPr sz="1275">
-              <a:solidFill>
-                <a:srgbClr val="44546A"/>
-              </a:solidFill>
-              <a:latin typeface="微软雅黑"/>
-              <a:ea typeface="微软雅黑"/>
-              <a:cs typeface="微软雅黑"/>
-            </a:endParaRPr>
+              <a:t>双轨校准</a:t>
+            </a:r>
+          </a:p>
+          <a:p>
+            <a:pPr marL="200025" indent="-200025">
+              <a:lnSpc>
+                <a:spcPct val="100000"/>
+              </a:lnSpc>
+              <a:spcAft>
+                <a:spcPts val="900"/>
+              </a:spcAft>
+              <a:buClr>
+                <a:srgbClr val="08A6F6"/>
+              </a:buClr>
+              <a:buFont typeface="Arial"/>
+              <a:buChar char="•"/>
+            </a:pPr>
+            <a:r>
+              <a:rPr lang="zh-CN" altLang="en-US" sz="1600">
+                <a:solidFill>
+                  <a:srgbClr val="44546A"/>
+                </a:solidFill>
+                <a:latin typeface="微软雅黑"/>
+                <a:ea typeface="微软雅黑"/>
+                <a:cs typeface="微软雅黑"/>
+              </a:rPr>
+              <a:t>数据飞轮</a:t>
+            </a:r>
+          </a:p>
+          <a:p>
+            <a:pPr marL="200025" indent="-200025">
+              <a:lnSpc>
+                <a:spcPct val="100000"/>
+              </a:lnSpc>
+              <a:spcAft>
+                <a:spcPts val="900"/>
+              </a:spcAft>
+              <a:buClr>
+                <a:srgbClr val="08A6F6"/>
+              </a:buClr>
+              <a:buFont typeface="Arial"/>
+              <a:buChar char="•"/>
+            </a:pPr>
+            <a:r>
+              <a:rPr lang="zh-CN" altLang="en-US" sz="1600">
+                <a:solidFill>
+                  <a:srgbClr val="44546A"/>
+                </a:solidFill>
+                <a:latin typeface="微软雅黑"/>
+                <a:ea typeface="微软雅黑"/>
+                <a:cs typeface="微软雅黑"/>
+              </a:rPr>
+              <a:t>核心团队</a:t>
+            </a:r>
           </a:p>
         </p:txBody>
       </p:sp>
@@ -1132,7 +1234,7 @@
         </p:nvSpPr>
         <p:spPr>
           <a:xfrm>
-            <a:off x="8104632" y="2009775"/>
+            <a:off x="8104632" y="2375535"/>
             <a:ext cx="3557016" cy="2466975"/>
           </a:xfrm>
           <a:custGeom>
@@ -1178,7 +1280,7 @@
         </p:nvSpPr>
         <p:spPr>
           <a:xfrm>
-            <a:off x="8104632" y="2231136"/>
+            <a:off x="8104632" y="2596896"/>
             <a:ext cx="3557016" cy="504825"/>
           </a:xfrm>
           <a:prstGeom prst="rect">
@@ -1227,7 +1329,7 @@
         </p:nvSpPr>
         <p:spPr>
           <a:xfrm>
-            <a:off x="8104632" y="2807207"/>
+            <a:off x="8104632" y="3172967"/>
             <a:ext cx="3557016" cy="548640"/>
           </a:xfrm>
           <a:prstGeom prst="rect">
@@ -1279,7 +1381,7 @@
         </p:nvSpPr>
         <p:spPr>
           <a:xfrm>
-            <a:off x="8104632" y="3474720"/>
+            <a:off x="8104632" y="3840480"/>
             <a:ext cx="3557016" cy="3291840"/>
           </a:xfrm>
           <a:prstGeom prst="rect">
@@ -1292,35 +1394,82 @@
           </a:bodyPr>
           <a:lstStyle/>
           <a:p>
-            <a:pPr>
+            <a:pPr marL="200025" indent="-200025">
               <a:lnSpc>
-                <a:spcPct val="150000"/>
+                <a:spcPct val="100000"/>
               </a:lnSpc>
-              <a:buNone/>
+              <a:spcAft>
+                <a:spcPts val="900"/>
+              </a:spcAft>
+              <a:buClr>
+                <a:srgbClr val="08A6F6"/>
+              </a:buClr>
+              <a:buFont typeface="Arial"/>
+              <a:buChar char="•"/>
             </a:pPr>
             <a:r>
-              <a:rPr sz="1275">
-                <a:solidFill>
-                  <a:srgbClr val="44546A">
-                    <a:alpha val="100000"/>
-                  </a:srgbClr>
-                </a:solidFill>
-                <a:latin typeface="微软雅黑"/>
-                <a:ea typeface="微软雅黑"/>
-                <a:cs typeface="微软雅黑"/>
-              </a:rPr>
-              <a:t>商业模式 · 融资规划 · 投资回报</a:t>
-            </a:r>
-            <a:endParaRPr sz="1275">
-              <a:solidFill>
-                <a:srgbClr val="44546A">
-                  <a:alpha val="100000"/>
-                </a:srgbClr>
-              </a:solidFill>
-              <a:latin typeface="微软雅黑"/>
-              <a:ea typeface="微软雅黑"/>
-              <a:cs typeface="微软雅黑"/>
-            </a:endParaRPr>
+              <a:rPr lang="zh-CN" altLang="en-US" sz="1600">
+                <a:solidFill>
+                  <a:srgbClr val="44546A"/>
+                </a:solidFill>
+                <a:latin typeface="微软雅黑"/>
+                <a:ea typeface="微软雅黑"/>
+                <a:cs typeface="微软雅黑"/>
+              </a:rPr>
+              <a:t>商业模式</a:t>
+            </a:r>
+          </a:p>
+          <a:p>
+            <a:pPr marL="200025" indent="-200025">
+              <a:lnSpc>
+                <a:spcPct val="100000"/>
+              </a:lnSpc>
+              <a:spcAft>
+                <a:spcPts val="900"/>
+              </a:spcAft>
+              <a:buClr>
+                <a:srgbClr val="08A6F6"/>
+              </a:buClr>
+              <a:buFont typeface="Arial"/>
+              <a:buChar char="•"/>
+            </a:pPr>
+            <a:r>
+              <a:rPr lang="zh-CN" altLang="en-US" sz="1600">
+                <a:solidFill>
+                  <a:srgbClr val="44546A"/>
+                </a:solidFill>
+                <a:latin typeface="微软雅黑"/>
+                <a:ea typeface="微软雅黑"/>
+                <a:cs typeface="微软雅黑"/>
+              </a:rPr>
+              <a:t>融资规划</a:t>
+            </a:r>
+          </a:p>
+          <a:p>
+            <a:pPr marL="200025" indent="-200025">
+              <a:lnSpc>
+                <a:spcPct val="100000"/>
+              </a:lnSpc>
+              <a:spcAft>
+                <a:spcPts val="900"/>
+              </a:spcAft>
+              <a:buClr>
+                <a:srgbClr val="08A6F6"/>
+              </a:buClr>
+              <a:buFont typeface="Arial"/>
+              <a:buChar char="•"/>
+            </a:pPr>
+            <a:r>
+              <a:rPr lang="zh-CN" altLang="en-US" sz="1600">
+                <a:solidFill>
+                  <a:srgbClr val="44546A"/>
+                </a:solidFill>
+                <a:latin typeface="微软雅黑"/>
+                <a:ea typeface="微软雅黑"/>
+                <a:cs typeface="微软雅黑"/>
+              </a:rPr>
+              <a:t>投资回报</a:t>
+            </a:r>
           </a:p>
         </p:txBody>
       </p:sp>

</xml_diff>